<commit_message>
added new figure pp
</commit_message>
<xml_diff>
--- a/output/figures/PP_figure_creation.pptx
+++ b/output/figures/PP_figure_creation.pptx
@@ -202,7 +202,7 @@
           <a:p>
             <a:fld id="{3C1211B4-146C-4B04-87A4-D58028F6A092}" type="datetimeFigureOut">
               <a:rPr lang="en-DE" smtClean="0"/>
-              <a:t>05/20/2025</a:t>
+              <a:t>07/01/2025</a:t>
             </a:fld>
             <a:endParaRPr lang="en-DE"/>
           </a:p>
@@ -1267,7 +1267,7 @@
           <a:p>
             <a:fld id="{5C4FE0DD-1D2D-421C-AE33-F119FAA9DCC7}" type="datetimeFigureOut">
               <a:rPr lang="en-DE" smtClean="0"/>
-              <a:t>05/20/2025</a:t>
+              <a:t>07/01/2025</a:t>
             </a:fld>
             <a:endParaRPr lang="en-DE"/>
           </a:p>
@@ -1467,7 +1467,7 @@
           <a:p>
             <a:fld id="{5C4FE0DD-1D2D-421C-AE33-F119FAA9DCC7}" type="datetimeFigureOut">
               <a:rPr lang="en-DE" smtClean="0"/>
-              <a:t>05/20/2025</a:t>
+              <a:t>07/01/2025</a:t>
             </a:fld>
             <a:endParaRPr lang="en-DE"/>
           </a:p>
@@ -1677,7 +1677,7 @@
           <a:p>
             <a:fld id="{5C4FE0DD-1D2D-421C-AE33-F119FAA9DCC7}" type="datetimeFigureOut">
               <a:rPr lang="en-DE" smtClean="0"/>
-              <a:t>05/20/2025</a:t>
+              <a:t>07/01/2025</a:t>
             </a:fld>
             <a:endParaRPr lang="en-DE"/>
           </a:p>
@@ -1877,7 +1877,7 @@
           <a:p>
             <a:fld id="{5C4FE0DD-1D2D-421C-AE33-F119FAA9DCC7}" type="datetimeFigureOut">
               <a:rPr lang="en-DE" smtClean="0"/>
-              <a:t>05/20/2025</a:t>
+              <a:t>07/01/2025</a:t>
             </a:fld>
             <a:endParaRPr lang="en-DE"/>
           </a:p>
@@ -2153,7 +2153,7 @@
           <a:p>
             <a:fld id="{5C4FE0DD-1D2D-421C-AE33-F119FAA9DCC7}" type="datetimeFigureOut">
               <a:rPr lang="en-DE" smtClean="0"/>
-              <a:t>05/20/2025</a:t>
+              <a:t>07/01/2025</a:t>
             </a:fld>
             <a:endParaRPr lang="en-DE"/>
           </a:p>
@@ -2421,7 +2421,7 @@
           <a:p>
             <a:fld id="{5C4FE0DD-1D2D-421C-AE33-F119FAA9DCC7}" type="datetimeFigureOut">
               <a:rPr lang="en-DE" smtClean="0"/>
-              <a:t>05/20/2025</a:t>
+              <a:t>07/01/2025</a:t>
             </a:fld>
             <a:endParaRPr lang="en-DE"/>
           </a:p>
@@ -2836,7 +2836,7 @@
           <a:p>
             <a:fld id="{5C4FE0DD-1D2D-421C-AE33-F119FAA9DCC7}" type="datetimeFigureOut">
               <a:rPr lang="en-DE" smtClean="0"/>
-              <a:t>05/20/2025</a:t>
+              <a:t>07/01/2025</a:t>
             </a:fld>
             <a:endParaRPr lang="en-DE"/>
           </a:p>
@@ -2978,7 +2978,7 @@
           <a:p>
             <a:fld id="{5C4FE0DD-1D2D-421C-AE33-F119FAA9DCC7}" type="datetimeFigureOut">
               <a:rPr lang="en-DE" smtClean="0"/>
-              <a:t>05/20/2025</a:t>
+              <a:t>07/01/2025</a:t>
             </a:fld>
             <a:endParaRPr lang="en-DE"/>
           </a:p>
@@ -3091,7 +3091,7 @@
           <a:p>
             <a:fld id="{5C4FE0DD-1D2D-421C-AE33-F119FAA9DCC7}" type="datetimeFigureOut">
               <a:rPr lang="en-DE" smtClean="0"/>
-              <a:t>05/20/2025</a:t>
+              <a:t>07/01/2025</a:t>
             </a:fld>
             <a:endParaRPr lang="en-DE"/>
           </a:p>
@@ -3404,7 +3404,7 @@
           <a:p>
             <a:fld id="{5C4FE0DD-1D2D-421C-AE33-F119FAA9DCC7}" type="datetimeFigureOut">
               <a:rPr lang="en-DE" smtClean="0"/>
-              <a:t>05/20/2025</a:t>
+              <a:t>07/01/2025</a:t>
             </a:fld>
             <a:endParaRPr lang="en-DE"/>
           </a:p>
@@ -3693,7 +3693,7 @@
           <a:p>
             <a:fld id="{5C4FE0DD-1D2D-421C-AE33-F119FAA9DCC7}" type="datetimeFigureOut">
               <a:rPr lang="en-DE" smtClean="0"/>
-              <a:t>05/20/2025</a:t>
+              <a:t>07/01/2025</a:t>
             </a:fld>
             <a:endParaRPr lang="en-DE"/>
           </a:p>
@@ -3936,7 +3936,7 @@
           <a:p>
             <a:fld id="{5C4FE0DD-1D2D-421C-AE33-F119FAA9DCC7}" type="datetimeFigureOut">
               <a:rPr lang="en-DE" smtClean="0"/>
-              <a:t>05/20/2025</a:t>
+              <a:t>07/01/2025</a:t>
             </a:fld>
             <a:endParaRPr lang="en-DE"/>
           </a:p>
@@ -4645,10 +4645,10 @@
       </p:sp>
       <p:grpSp>
         <p:nvGrpSpPr>
-          <p:cNvPr id="114" name="Group 113">
+          <p:cNvPr id="104" name="Group 103">
             <a:extLst>
               <a:ext uri="{FF2B5EF4-FFF2-40B4-BE49-F238E27FC236}">
-                <a16:creationId xmlns:a16="http://schemas.microsoft.com/office/drawing/2014/main" id="{37B1F989-5C2E-1A82-189D-4D6158C88F38}"/>
+                <a16:creationId xmlns:a16="http://schemas.microsoft.com/office/drawing/2014/main" id="{9941BBB4-BD90-E708-0C84-83CC7B3F1C92}"/>
               </a:ext>
             </a:extLst>
           </p:cNvPr>
@@ -8368,6 +8368,626 @@
             </a:p>
           </p:txBody>
         </p:sp>
+        <p:sp>
+          <p:nvSpPr>
+            <p:cNvPr id="2" name="Rectangle 1">
+              <a:extLst>
+                <a:ext uri="{FF2B5EF4-FFF2-40B4-BE49-F238E27FC236}">
+                  <a16:creationId xmlns:a16="http://schemas.microsoft.com/office/drawing/2014/main" id="{1962D2A9-248E-4749-3C3F-441DE3996542}"/>
+                </a:ext>
+              </a:extLst>
+            </p:cNvPr>
+            <p:cNvSpPr/>
+            <p:nvPr/>
+          </p:nvSpPr>
+          <p:spPr>
+            <a:xfrm>
+              <a:off x="3843339" y="4175796"/>
+              <a:ext cx="174712" cy="919162"/>
+            </a:xfrm>
+            <a:prstGeom prst="rect">
+              <a:avLst/>
+            </a:prstGeom>
+            <a:solidFill>
+              <a:schemeClr val="bg1"/>
+            </a:solidFill>
+            <a:ln>
+              <a:solidFill>
+                <a:schemeClr val="bg1"/>
+              </a:solidFill>
+            </a:ln>
+          </p:spPr>
+          <p:style>
+            <a:lnRef idx="2">
+              <a:schemeClr val="accent1">
+                <a:shade val="15000"/>
+              </a:schemeClr>
+            </a:lnRef>
+            <a:fillRef idx="1">
+              <a:schemeClr val="accent1"/>
+            </a:fillRef>
+            <a:effectRef idx="0">
+              <a:schemeClr val="accent1"/>
+            </a:effectRef>
+            <a:fontRef idx="minor">
+              <a:schemeClr val="lt1"/>
+            </a:fontRef>
+          </p:style>
+          <p:txBody>
+            <a:bodyPr rtlCol="0" anchor="ctr"/>
+            <a:lstStyle/>
+            <a:p>
+              <a:pPr algn="ctr"/>
+              <a:endParaRPr lang="de-DE"/>
+            </a:p>
+          </p:txBody>
+        </p:sp>
+        <p:sp>
+          <p:nvSpPr>
+            <p:cNvPr id="6" name="Rectangle 5">
+              <a:extLst>
+                <a:ext uri="{FF2B5EF4-FFF2-40B4-BE49-F238E27FC236}">
+                  <a16:creationId xmlns:a16="http://schemas.microsoft.com/office/drawing/2014/main" id="{EC03ED48-635B-91D8-5EC8-F817274A51DC}"/>
+                </a:ext>
+              </a:extLst>
+            </p:cNvPr>
+            <p:cNvSpPr/>
+            <p:nvPr/>
+          </p:nvSpPr>
+          <p:spPr>
+            <a:xfrm>
+              <a:off x="3843338" y="516539"/>
+              <a:ext cx="184237" cy="919162"/>
+            </a:xfrm>
+            <a:prstGeom prst="rect">
+              <a:avLst/>
+            </a:prstGeom>
+            <a:solidFill>
+              <a:schemeClr val="bg1"/>
+            </a:solidFill>
+            <a:ln>
+              <a:solidFill>
+                <a:schemeClr val="bg1"/>
+              </a:solidFill>
+            </a:ln>
+          </p:spPr>
+          <p:style>
+            <a:lnRef idx="2">
+              <a:schemeClr val="accent1">
+                <a:shade val="15000"/>
+              </a:schemeClr>
+            </a:lnRef>
+            <a:fillRef idx="1">
+              <a:schemeClr val="accent1"/>
+            </a:fillRef>
+            <a:effectRef idx="0">
+              <a:schemeClr val="accent1"/>
+            </a:effectRef>
+            <a:fontRef idx="minor">
+              <a:schemeClr val="lt1"/>
+            </a:fontRef>
+          </p:style>
+          <p:txBody>
+            <a:bodyPr rtlCol="0" anchor="ctr"/>
+            <a:lstStyle/>
+            <a:p>
+              <a:pPr algn="ctr"/>
+              <a:endParaRPr lang="de-DE"/>
+            </a:p>
+          </p:txBody>
+        </p:sp>
+        <p:sp>
+          <p:nvSpPr>
+            <p:cNvPr id="70" name="Rectangle 69">
+              <a:extLst>
+                <a:ext uri="{FF2B5EF4-FFF2-40B4-BE49-F238E27FC236}">
+                  <a16:creationId xmlns:a16="http://schemas.microsoft.com/office/drawing/2014/main" id="{54EE3D31-560F-AFA4-C46C-6BC157249A64}"/>
+                </a:ext>
+              </a:extLst>
+            </p:cNvPr>
+            <p:cNvSpPr/>
+            <p:nvPr/>
+          </p:nvSpPr>
+          <p:spPr>
+            <a:xfrm>
+              <a:off x="4018051" y="4913914"/>
+              <a:ext cx="133438" cy="237069"/>
+            </a:xfrm>
+            <a:prstGeom prst="rect">
+              <a:avLst/>
+            </a:prstGeom>
+            <a:solidFill>
+              <a:schemeClr val="bg1"/>
+            </a:solidFill>
+            <a:ln>
+              <a:noFill/>
+            </a:ln>
+          </p:spPr>
+          <p:style>
+            <a:lnRef idx="2">
+              <a:schemeClr val="accent1">
+                <a:shade val="15000"/>
+              </a:schemeClr>
+            </a:lnRef>
+            <a:fillRef idx="1">
+              <a:schemeClr val="accent1"/>
+            </a:fillRef>
+            <a:effectRef idx="0">
+              <a:schemeClr val="accent1"/>
+            </a:effectRef>
+            <a:fontRef idx="minor">
+              <a:schemeClr val="lt1"/>
+            </a:fontRef>
+          </p:style>
+          <p:txBody>
+            <a:bodyPr rtlCol="0" anchor="ctr"/>
+            <a:lstStyle/>
+            <a:p>
+              <a:pPr algn="ctr"/>
+              <a:r>
+                <a:rPr lang="en-GB" sz="800" dirty="0">
+                  <a:solidFill>
+                    <a:schemeClr val="tx1"/>
+                  </a:solidFill>
+                </a:rPr>
+                <a:t>4</a:t>
+              </a:r>
+              <a:endParaRPr lang="de-DE" sz="800" dirty="0">
+                <a:solidFill>
+                  <a:schemeClr val="tx1"/>
+                </a:solidFill>
+              </a:endParaRPr>
+            </a:p>
+          </p:txBody>
+        </p:sp>
+        <p:sp>
+          <p:nvSpPr>
+            <p:cNvPr id="76" name="Rectangle 75">
+              <a:extLst>
+                <a:ext uri="{FF2B5EF4-FFF2-40B4-BE49-F238E27FC236}">
+                  <a16:creationId xmlns:a16="http://schemas.microsoft.com/office/drawing/2014/main" id="{36381D2F-74B4-1FD0-11FC-532E9F830124}"/>
+                </a:ext>
+              </a:extLst>
+            </p:cNvPr>
+            <p:cNvSpPr/>
+            <p:nvPr/>
+          </p:nvSpPr>
+          <p:spPr>
+            <a:xfrm>
+              <a:off x="4018051" y="4199539"/>
+              <a:ext cx="133438" cy="237069"/>
+            </a:xfrm>
+            <a:prstGeom prst="rect">
+              <a:avLst/>
+            </a:prstGeom>
+            <a:solidFill>
+              <a:schemeClr val="bg1"/>
+            </a:solidFill>
+            <a:ln>
+              <a:noFill/>
+            </a:ln>
+          </p:spPr>
+          <p:style>
+            <a:lnRef idx="2">
+              <a:schemeClr val="accent1">
+                <a:shade val="15000"/>
+              </a:schemeClr>
+            </a:lnRef>
+            <a:fillRef idx="1">
+              <a:schemeClr val="accent1"/>
+            </a:fillRef>
+            <a:effectRef idx="0">
+              <a:schemeClr val="accent1"/>
+            </a:effectRef>
+            <a:fontRef idx="minor">
+              <a:schemeClr val="lt1"/>
+            </a:fontRef>
+          </p:style>
+          <p:txBody>
+            <a:bodyPr rtlCol="0" anchor="ctr"/>
+            <a:lstStyle/>
+            <a:p>
+              <a:pPr algn="ctr"/>
+              <a:r>
+                <a:rPr lang="en-GB" sz="800" dirty="0">
+                  <a:solidFill>
+                    <a:schemeClr val="tx1"/>
+                  </a:solidFill>
+                </a:rPr>
+                <a:t>0</a:t>
+              </a:r>
+              <a:endParaRPr lang="de-DE" sz="800" dirty="0">
+                <a:solidFill>
+                  <a:schemeClr val="tx1"/>
+                </a:solidFill>
+              </a:endParaRPr>
+            </a:p>
+          </p:txBody>
+        </p:sp>
+        <p:sp>
+          <p:nvSpPr>
+            <p:cNvPr id="93" name="Rectangle 92">
+              <a:extLst>
+                <a:ext uri="{FF2B5EF4-FFF2-40B4-BE49-F238E27FC236}">
+                  <a16:creationId xmlns:a16="http://schemas.microsoft.com/office/drawing/2014/main" id="{868D3C52-7FD3-7979-E333-234D53221745}"/>
+                </a:ext>
+              </a:extLst>
+            </p:cNvPr>
+            <p:cNvSpPr/>
+            <p:nvPr/>
+          </p:nvSpPr>
+          <p:spPr>
+            <a:xfrm>
+              <a:off x="5208691" y="4832948"/>
+              <a:ext cx="133438" cy="237069"/>
+            </a:xfrm>
+            <a:prstGeom prst="rect">
+              <a:avLst/>
+            </a:prstGeom>
+            <a:solidFill>
+              <a:schemeClr val="bg1"/>
+            </a:solidFill>
+            <a:ln>
+              <a:noFill/>
+            </a:ln>
+          </p:spPr>
+          <p:style>
+            <a:lnRef idx="2">
+              <a:schemeClr val="accent1">
+                <a:shade val="15000"/>
+              </a:schemeClr>
+            </a:lnRef>
+            <a:fillRef idx="1">
+              <a:schemeClr val="accent1"/>
+            </a:fillRef>
+            <a:effectRef idx="0">
+              <a:schemeClr val="accent1"/>
+            </a:effectRef>
+            <a:fontRef idx="minor">
+              <a:schemeClr val="lt1"/>
+            </a:fontRef>
+          </p:style>
+          <p:txBody>
+            <a:bodyPr lIns="0" tIns="0" rIns="0" bIns="0" rtlCol="0" anchor="ctr"/>
+            <a:lstStyle/>
+            <a:p>
+              <a:pPr algn="ctr"/>
+              <a:r>
+                <a:rPr lang="en-GB" sz="800" dirty="0">
+                  <a:solidFill>
+                    <a:schemeClr val="tx1"/>
+                  </a:solidFill>
+                </a:rPr>
+                <a:t>40</a:t>
+              </a:r>
+              <a:endParaRPr lang="de-DE" sz="800" dirty="0">
+                <a:solidFill>
+                  <a:schemeClr val="tx1"/>
+                </a:solidFill>
+              </a:endParaRPr>
+            </a:p>
+          </p:txBody>
+        </p:sp>
+        <p:sp>
+          <p:nvSpPr>
+            <p:cNvPr id="94" name="Rectangle 93">
+              <a:extLst>
+                <a:ext uri="{FF2B5EF4-FFF2-40B4-BE49-F238E27FC236}">
+                  <a16:creationId xmlns:a16="http://schemas.microsoft.com/office/drawing/2014/main" id="{609765E1-7549-BE64-11E0-9419911A9CF1}"/>
+                </a:ext>
+              </a:extLst>
+            </p:cNvPr>
+            <p:cNvSpPr/>
+            <p:nvPr/>
+          </p:nvSpPr>
+          <p:spPr>
+            <a:xfrm>
+              <a:off x="5208691" y="4094758"/>
+              <a:ext cx="133438" cy="237069"/>
+            </a:xfrm>
+            <a:prstGeom prst="rect">
+              <a:avLst/>
+            </a:prstGeom>
+            <a:solidFill>
+              <a:schemeClr val="bg1"/>
+            </a:solidFill>
+            <a:ln>
+              <a:noFill/>
+            </a:ln>
+          </p:spPr>
+          <p:style>
+            <a:lnRef idx="2">
+              <a:schemeClr val="accent1">
+                <a:shade val="15000"/>
+              </a:schemeClr>
+            </a:lnRef>
+            <a:fillRef idx="1">
+              <a:schemeClr val="accent1"/>
+            </a:fillRef>
+            <a:effectRef idx="0">
+              <a:schemeClr val="accent1"/>
+            </a:effectRef>
+            <a:fontRef idx="minor">
+              <a:schemeClr val="lt1"/>
+            </a:fontRef>
+          </p:style>
+          <p:txBody>
+            <a:bodyPr lIns="0" tIns="0" rIns="0" bIns="0" rtlCol="0" anchor="ctr"/>
+            <a:lstStyle/>
+            <a:p>
+              <a:pPr algn="ctr"/>
+              <a:r>
+                <a:rPr lang="en-GB" sz="800" dirty="0">
+                  <a:solidFill>
+                    <a:schemeClr val="tx1"/>
+                  </a:solidFill>
+                </a:rPr>
+                <a:t>20</a:t>
+              </a:r>
+              <a:endParaRPr lang="de-DE" sz="800" dirty="0">
+                <a:solidFill>
+                  <a:schemeClr val="tx1"/>
+                </a:solidFill>
+              </a:endParaRPr>
+            </a:p>
+          </p:txBody>
+        </p:sp>
+        <p:sp>
+          <p:nvSpPr>
+            <p:cNvPr id="100" name="Rectangle 99">
+              <a:extLst>
+                <a:ext uri="{FF2B5EF4-FFF2-40B4-BE49-F238E27FC236}">
+                  <a16:creationId xmlns:a16="http://schemas.microsoft.com/office/drawing/2014/main" id="{3FF2AE10-F334-5736-05E0-F20C26DC3C94}"/>
+                </a:ext>
+              </a:extLst>
+            </p:cNvPr>
+            <p:cNvSpPr/>
+            <p:nvPr/>
+          </p:nvSpPr>
+          <p:spPr>
+            <a:xfrm>
+              <a:off x="4018051" y="1281714"/>
+              <a:ext cx="133438" cy="237069"/>
+            </a:xfrm>
+            <a:prstGeom prst="rect">
+              <a:avLst/>
+            </a:prstGeom>
+            <a:solidFill>
+              <a:schemeClr val="bg1"/>
+            </a:solidFill>
+            <a:ln>
+              <a:noFill/>
+            </a:ln>
+          </p:spPr>
+          <p:style>
+            <a:lnRef idx="2">
+              <a:schemeClr val="accent1">
+                <a:shade val="15000"/>
+              </a:schemeClr>
+            </a:lnRef>
+            <a:fillRef idx="1">
+              <a:schemeClr val="accent1"/>
+            </a:fillRef>
+            <a:effectRef idx="0">
+              <a:schemeClr val="accent1"/>
+            </a:effectRef>
+            <a:fontRef idx="minor">
+              <a:schemeClr val="lt1"/>
+            </a:fontRef>
+          </p:style>
+          <p:txBody>
+            <a:bodyPr rtlCol="0" anchor="ctr"/>
+            <a:lstStyle/>
+            <a:p>
+              <a:pPr algn="ctr"/>
+              <a:r>
+                <a:rPr lang="en-GB" sz="800" dirty="0">
+                  <a:solidFill>
+                    <a:schemeClr val="tx1"/>
+                  </a:solidFill>
+                </a:rPr>
+                <a:t>4</a:t>
+              </a:r>
+              <a:endParaRPr lang="de-DE" sz="800" dirty="0">
+                <a:solidFill>
+                  <a:schemeClr val="tx1"/>
+                </a:solidFill>
+              </a:endParaRPr>
+            </a:p>
+          </p:txBody>
+        </p:sp>
+        <p:sp>
+          <p:nvSpPr>
+            <p:cNvPr id="101" name="Rectangle 100">
+              <a:extLst>
+                <a:ext uri="{FF2B5EF4-FFF2-40B4-BE49-F238E27FC236}">
+                  <a16:creationId xmlns:a16="http://schemas.microsoft.com/office/drawing/2014/main" id="{C460FC19-E19B-2549-11F0-2469DBA67B47}"/>
+                </a:ext>
+              </a:extLst>
+            </p:cNvPr>
+            <p:cNvSpPr/>
+            <p:nvPr/>
+          </p:nvSpPr>
+          <p:spPr>
+            <a:xfrm>
+              <a:off x="4018051" y="567339"/>
+              <a:ext cx="133438" cy="237069"/>
+            </a:xfrm>
+            <a:prstGeom prst="rect">
+              <a:avLst/>
+            </a:prstGeom>
+            <a:solidFill>
+              <a:schemeClr val="bg1"/>
+            </a:solidFill>
+            <a:ln>
+              <a:noFill/>
+            </a:ln>
+          </p:spPr>
+          <p:style>
+            <a:lnRef idx="2">
+              <a:schemeClr val="accent1">
+                <a:shade val="15000"/>
+              </a:schemeClr>
+            </a:lnRef>
+            <a:fillRef idx="1">
+              <a:schemeClr val="accent1"/>
+            </a:fillRef>
+            <a:effectRef idx="0">
+              <a:schemeClr val="accent1"/>
+            </a:effectRef>
+            <a:fontRef idx="minor">
+              <a:schemeClr val="lt1"/>
+            </a:fontRef>
+          </p:style>
+          <p:txBody>
+            <a:bodyPr rtlCol="0" anchor="ctr"/>
+            <a:lstStyle/>
+            <a:p>
+              <a:pPr algn="ctr"/>
+              <a:r>
+                <a:rPr lang="en-GB" sz="800" dirty="0">
+                  <a:solidFill>
+                    <a:schemeClr val="tx1"/>
+                  </a:solidFill>
+                </a:rPr>
+                <a:t>0</a:t>
+              </a:r>
+              <a:endParaRPr lang="de-DE" sz="800" dirty="0">
+                <a:solidFill>
+                  <a:schemeClr val="tx1"/>
+                </a:solidFill>
+              </a:endParaRPr>
+            </a:p>
+          </p:txBody>
+        </p:sp>
+        <p:sp>
+          <p:nvSpPr>
+            <p:cNvPr id="102" name="Rectangle 101">
+              <a:extLst>
+                <a:ext uri="{FF2B5EF4-FFF2-40B4-BE49-F238E27FC236}">
+                  <a16:creationId xmlns:a16="http://schemas.microsoft.com/office/drawing/2014/main" id="{F8AF9167-1CA9-8235-50AA-3FA5545692EA}"/>
+                </a:ext>
+              </a:extLst>
+            </p:cNvPr>
+            <p:cNvSpPr/>
+            <p:nvPr/>
+          </p:nvSpPr>
+          <p:spPr>
+            <a:xfrm>
+              <a:off x="5208691" y="1200748"/>
+              <a:ext cx="133438" cy="237069"/>
+            </a:xfrm>
+            <a:prstGeom prst="rect">
+              <a:avLst/>
+            </a:prstGeom>
+            <a:solidFill>
+              <a:schemeClr val="bg1"/>
+            </a:solidFill>
+            <a:ln>
+              <a:noFill/>
+            </a:ln>
+          </p:spPr>
+          <p:style>
+            <a:lnRef idx="2">
+              <a:schemeClr val="accent1">
+                <a:shade val="15000"/>
+              </a:schemeClr>
+            </a:lnRef>
+            <a:fillRef idx="1">
+              <a:schemeClr val="accent1"/>
+            </a:fillRef>
+            <a:effectRef idx="0">
+              <a:schemeClr val="accent1"/>
+            </a:effectRef>
+            <a:fontRef idx="minor">
+              <a:schemeClr val="lt1"/>
+            </a:fontRef>
+          </p:style>
+          <p:txBody>
+            <a:bodyPr lIns="0" tIns="0" rIns="0" bIns="0" rtlCol="0" anchor="ctr"/>
+            <a:lstStyle/>
+            <a:p>
+              <a:pPr algn="ctr"/>
+              <a:r>
+                <a:rPr lang="en-GB" sz="800" dirty="0">
+                  <a:solidFill>
+                    <a:schemeClr val="tx1"/>
+                  </a:solidFill>
+                </a:rPr>
+                <a:t>40</a:t>
+              </a:r>
+              <a:endParaRPr lang="de-DE" sz="800" dirty="0">
+                <a:solidFill>
+                  <a:schemeClr val="tx1"/>
+                </a:solidFill>
+              </a:endParaRPr>
+            </a:p>
+          </p:txBody>
+        </p:sp>
+        <p:sp>
+          <p:nvSpPr>
+            <p:cNvPr id="103" name="Rectangle 102">
+              <a:extLst>
+                <a:ext uri="{FF2B5EF4-FFF2-40B4-BE49-F238E27FC236}">
+                  <a16:creationId xmlns:a16="http://schemas.microsoft.com/office/drawing/2014/main" id="{F9943B7A-1877-CC63-ABF7-9E0BF099B128}"/>
+                </a:ext>
+              </a:extLst>
+            </p:cNvPr>
+            <p:cNvSpPr/>
+            <p:nvPr/>
+          </p:nvSpPr>
+          <p:spPr>
+            <a:xfrm>
+              <a:off x="5208691" y="462558"/>
+              <a:ext cx="133438" cy="237069"/>
+            </a:xfrm>
+            <a:prstGeom prst="rect">
+              <a:avLst/>
+            </a:prstGeom>
+            <a:solidFill>
+              <a:schemeClr val="bg1"/>
+            </a:solidFill>
+            <a:ln>
+              <a:noFill/>
+            </a:ln>
+          </p:spPr>
+          <p:style>
+            <a:lnRef idx="2">
+              <a:schemeClr val="accent1">
+                <a:shade val="15000"/>
+              </a:schemeClr>
+            </a:lnRef>
+            <a:fillRef idx="1">
+              <a:schemeClr val="accent1"/>
+            </a:fillRef>
+            <a:effectRef idx="0">
+              <a:schemeClr val="accent1"/>
+            </a:effectRef>
+            <a:fontRef idx="minor">
+              <a:schemeClr val="lt1"/>
+            </a:fontRef>
+          </p:style>
+          <p:txBody>
+            <a:bodyPr lIns="0" tIns="0" rIns="0" bIns="0" rtlCol="0" anchor="ctr"/>
+            <a:lstStyle/>
+            <a:p>
+              <a:pPr algn="ctr"/>
+              <a:r>
+                <a:rPr lang="en-GB" sz="800" dirty="0">
+                  <a:solidFill>
+                    <a:schemeClr val="tx1"/>
+                  </a:solidFill>
+                </a:rPr>
+                <a:t>20</a:t>
+              </a:r>
+              <a:endParaRPr lang="de-DE" sz="800" dirty="0">
+                <a:solidFill>
+                  <a:schemeClr val="tx1"/>
+                </a:solidFill>
+              </a:endParaRPr>
+            </a:p>
+          </p:txBody>
+        </p:sp>
       </p:grpSp>
     </p:spTree>
     <p:extLst>

</xml_diff>